<commit_message>
Optimize sliders grid and scenario metrics responsiveness for narrow mobile viewports
</commit_message>
<xml_diff>
--- a/People's Priorities.pptx
+++ b/People's Priorities.pptx
@@ -13703,6 +13703,13 @@
             <a:schemeClr val="lt1"/>
           </a:fontRef>
         </p:style>
+        <p:txBody>
+          <a:bodyPr/>
+          <a:lstStyle/>
+          <a:p>
+            <a:endParaRPr lang="en-IN"/>
+          </a:p>
+        </p:txBody>
       </p:sp>
       <p:sp>
         <p:nvSpPr>
@@ -14207,6 +14214,13 @@
             <a:schemeClr val="lt1"/>
           </a:fontRef>
         </p:style>
+        <p:txBody>
+          <a:bodyPr/>
+          <a:lstStyle/>
+          <a:p>
+            <a:endParaRPr lang="en-IN"/>
+          </a:p>
+        </p:txBody>
       </p:sp>
       <p:sp>
         <p:nvSpPr>
@@ -14343,6 +14357,13 @@
             <a:schemeClr val="lt1"/>
           </a:fontRef>
         </p:style>
+        <p:txBody>
+          <a:bodyPr/>
+          <a:lstStyle/>
+          <a:p>
+            <a:endParaRPr lang="en-IN"/>
+          </a:p>
+        </p:txBody>
       </p:sp>
       <p:sp>
         <p:nvSpPr>
@@ -14386,6 +14407,13 @@
             <a:schemeClr val="lt1"/>
           </a:fontRef>
         </p:style>
+        <p:txBody>
+          <a:bodyPr/>
+          <a:lstStyle/>
+          <a:p>
+            <a:endParaRPr lang="en-IN"/>
+          </a:p>
+        </p:txBody>
       </p:sp>
       <p:sp>
         <p:nvSpPr>
@@ -14429,6 +14457,13 @@
             <a:schemeClr val="lt1"/>
           </a:fontRef>
         </p:style>
+        <p:txBody>
+          <a:bodyPr/>
+          <a:lstStyle/>
+          <a:p>
+            <a:endParaRPr lang="en-IN"/>
+          </a:p>
+        </p:txBody>
       </p:sp>
       <p:sp>
         <p:nvSpPr>
@@ -14779,6 +14814,13 @@
             <a:schemeClr val="lt1"/>
           </a:fontRef>
         </p:style>
+        <p:txBody>
+          <a:bodyPr/>
+          <a:lstStyle/>
+          <a:p>
+            <a:endParaRPr lang="en-IN"/>
+          </a:p>
+        </p:txBody>
       </p:sp>
       <p:sp>
         <p:nvSpPr>
@@ -15972,6 +16014,13 @@
             <a:schemeClr val="lt1"/>
           </a:fontRef>
         </p:style>
+        <p:txBody>
+          <a:bodyPr/>
+          <a:lstStyle/>
+          <a:p>
+            <a:endParaRPr lang="en-IN"/>
+          </a:p>
+        </p:txBody>
       </p:sp>
       <p:sp>
         <p:nvSpPr>
@@ -16863,6 +16912,13 @@
             <a:schemeClr val="lt1"/>
           </a:fontRef>
         </p:style>
+        <p:txBody>
+          <a:bodyPr/>
+          <a:lstStyle/>
+          <a:p>
+            <a:endParaRPr lang="en-IN"/>
+          </a:p>
+        </p:txBody>
       </p:sp>
       <p:sp>
         <p:nvSpPr>
@@ -16900,6 +16956,13 @@
             <a:schemeClr val="lt1"/>
           </a:fontRef>
         </p:style>
+        <p:txBody>
+          <a:bodyPr/>
+          <a:lstStyle/>
+          <a:p>
+            <a:endParaRPr lang="en-IN"/>
+          </a:p>
+        </p:txBody>
       </p:sp>
       <p:sp>
         <p:nvSpPr>
@@ -16937,6 +17000,13 @@
             <a:schemeClr val="lt1"/>
           </a:fontRef>
         </p:style>
+        <p:txBody>
+          <a:bodyPr/>
+          <a:lstStyle/>
+          <a:p>
+            <a:endParaRPr lang="en-IN"/>
+          </a:p>
+        </p:txBody>
       </p:sp>
     </p:spTree>
     <p:extLst>
@@ -17578,6 +17648,13 @@
             <a:schemeClr val="lt1"/>
           </a:fontRef>
         </p:style>
+        <p:txBody>
+          <a:bodyPr/>
+          <a:lstStyle/>
+          <a:p>
+            <a:endParaRPr lang="en-IN"/>
+          </a:p>
+        </p:txBody>
       </p:sp>
       <p:sp>
         <p:nvSpPr>
@@ -17632,6 +17709,13 @@
             <a:schemeClr val="lt1"/>
           </a:fontRef>
         </p:style>
+        <p:txBody>
+          <a:bodyPr/>
+          <a:lstStyle/>
+          <a:p>
+            <a:endParaRPr lang="en-IN"/>
+          </a:p>
+        </p:txBody>
       </p:sp>
       <p:sp>
         <p:nvSpPr>
@@ -17686,6 +17770,13 @@
             <a:schemeClr val="lt1"/>
           </a:fontRef>
         </p:style>
+        <p:txBody>
+          <a:bodyPr/>
+          <a:lstStyle/>
+          <a:p>
+            <a:endParaRPr lang="en-IN"/>
+          </a:p>
+        </p:txBody>
       </p:sp>
       <p:pic>
         <p:nvPicPr>
@@ -18856,19 +18947,8 @@
                 <a:latin typeface="Times New Roman" panose="02020603050405020304" pitchFamily="18" charset="0"/>
                 <a:cs typeface="Times New Roman" panose="02020603050405020304" pitchFamily="18" charset="0"/>
               </a:rPr>
-              <a:t>Technology Stack: Next.js | Supabase PostgreSQL | Gemini AI | Leaflet | Recharts | </a:t>
+              <a:t>Technology Stack: Next.js | Supabase PostgreSQL | Gemini AI | Leaflet | Recharts | pgvector</a:t>
             </a:r>
-            <a:r>
-              <a:rPr lang="en-IN" dirty="0" err="1">
-                <a:latin typeface="Times New Roman" panose="02020603050405020304" pitchFamily="18" charset="0"/>
-                <a:cs typeface="Times New Roman" panose="02020603050405020304" pitchFamily="18" charset="0"/>
-              </a:rPr>
-              <a:t>pgvector</a:t>
-            </a:r>
-            <a:endParaRPr lang="en-IN" dirty="0">
-              <a:latin typeface="Times New Roman" panose="02020603050405020304" pitchFamily="18" charset="0"/>
-              <a:cs typeface="Times New Roman" panose="02020603050405020304" pitchFamily="18" charset="0"/>
-            </a:endParaRPr>
           </a:p>
           <a:p>
             <a:endParaRPr lang="en-IN" dirty="0">
@@ -20161,6 +20241,13 @@
               <a:schemeClr val="lt1"/>
             </a:fontRef>
           </p:style>
+          <p:txBody>
+            <a:bodyPr/>
+            <a:lstStyle/>
+            <a:p>
+              <a:endParaRPr lang="en-IN"/>
+            </a:p>
+          </p:txBody>
         </p:sp>
         <p:sp>
           <p:nvSpPr>
@@ -20362,6 +20449,13 @@
               <a:schemeClr val="lt1"/>
             </a:fontRef>
           </p:style>
+          <p:txBody>
+            <a:bodyPr/>
+            <a:lstStyle/>
+            <a:p>
+              <a:endParaRPr lang="en-IN"/>
+            </a:p>
+          </p:txBody>
         </p:sp>
         <p:sp>
           <p:nvSpPr>
@@ -20559,6 +20653,13 @@
               <a:schemeClr val="lt1"/>
             </a:fontRef>
           </p:style>
+          <p:txBody>
+            <a:bodyPr/>
+            <a:lstStyle/>
+            <a:p>
+              <a:endParaRPr lang="en-IN"/>
+            </a:p>
+          </p:txBody>
         </p:sp>
         <p:sp>
           <p:nvSpPr>
@@ -20860,7 +20961,7 @@
         </p:nvSpPr>
         <p:spPr>
           <a:xfrm>
-            <a:off x="590335" y="2250891"/>
+            <a:off x="590335" y="1857699"/>
             <a:ext cx="5194769" cy="557784"/>
           </a:xfrm>
         </p:spPr>
@@ -20906,8 +21007,8 @@
         </p:blipFill>
         <p:spPr>
           <a:xfrm>
-            <a:off x="590335" y="2724884"/>
-            <a:ext cx="4841201" cy="3939409"/>
+            <a:off x="590336" y="2415484"/>
+            <a:ext cx="5066872" cy="4248810"/>
           </a:xfrm>
           <a:prstGeom prst="rect">
             <a:avLst/>
@@ -20932,7 +21033,7 @@
         </p:nvSpPr>
         <p:spPr>
           <a:xfrm>
-            <a:off x="6425183" y="2250892"/>
+            <a:off x="6425183" y="1862110"/>
             <a:ext cx="5194770" cy="553373"/>
           </a:xfrm>
         </p:spPr>
@@ -20978,8 +21079,8 @@
         </p:blipFill>
         <p:spPr>
           <a:xfrm>
-            <a:off x="6143198" y="2722967"/>
-            <a:ext cx="5245226" cy="3939408"/>
+            <a:off x="5888736" y="2413565"/>
+            <a:ext cx="5499688" cy="4248810"/>
           </a:xfrm>
           <a:prstGeom prst="rect">
             <a:avLst/>
@@ -21199,18 +21300,11 @@
           <a:p>
             <a:pPr lvl="1"/>
             <a:r>
-              <a:rPr lang="en-IN" sz="1600" dirty="0" err="1">
-                <a:latin typeface="Times New Roman" panose="02020603050405020304" pitchFamily="18" charset="0"/>
-                <a:cs typeface="Times New Roman" panose="02020603050405020304" pitchFamily="18" charset="0"/>
-              </a:rPr>
-              <a:t>pgvector</a:t>
-            </a:r>
-            <a:r>
               <a:rPr lang="en-IN" sz="1600" dirty="0">
                 <a:latin typeface="Times New Roman" panose="02020603050405020304" pitchFamily="18" charset="0"/>
                 <a:cs typeface="Times New Roman" panose="02020603050405020304" pitchFamily="18" charset="0"/>
               </a:rPr>
-              <a:t> </a:t>
+              <a:t>pgvector </a:t>
             </a:r>
           </a:p>
           <a:p>

</xml_diff>